<commit_message>
fixed the kv cache size desc
</commit_message>
<xml_diff>
--- a/talk/deck.pptx
+++ b/talk/deck.pptx
@@ -1249,7 +1249,7 @@
           <a:p/>
           <a:p>
             <a:r>
-              <a:t>Prefix caching: only helps when prompts share prefixes. Sizing the KV cache and monitoring hit rate keeps it honest in production.</a:t>
+              <a:t>Prefix caching: only helps when prompts share prefixes. Footprint is per unique prefix (128 KiB / token), not per user — one shared system prompt costs the same whether 1 or 10,000 users hit it. What drives the cost is prompt length, and (in multi-tenant setups) the number of distinct prefixes cached in parallel. Size the KV cache to prompt length and monitor hit rate.</a:t>
             </a:r>
           </a:p>
           <a:p/>
@@ -10704,7 +10704,7 @@
                           </a:solidFill>
                           <a:latin typeface="Calibri"/>
                         </a:rPr>
-                        <a:t>Cache miss = no benefit; memory overhead</a:t>
+                        <a:t>Cache miss = no benefit; footprint scales with prompt length (not user count when prefixes are shared)</a:t>
                       </a:r>
                     </a:p>
                   </a:txBody>
@@ -10726,7 +10726,7 @@
                           </a:solidFill>
                           <a:latin typeface="Calibri"/>
                         </a:rPr>
-                        <a:t>Size KV cache to workload; monitor hit rate</a:t>
+                        <a:t>Size KV cache to prompt length; monitor hit rate</a:t>
                       </a:r>
                     </a:p>
                   </a:txBody>

</xml_diff>